<commit_message>
fix presentation and gitb pages issues
</commit_message>
<xml_diff>
--- a/presentation/llm-wiki-deck.pptx
+++ b/presentation/llm-wiki-deck.pptx
@@ -865,101 +865,106 @@
           <a:p/>
           <a:p>
             <a:r>
-              <a:t>The system works with both Claude Code CLI and GitHub Copilot Chat — use whichever you already have.</a:t>
+              <a:t>The system works with both Claude Code CLI and GitHub Copilot Chat.</a:t>
             </a:r>
           </a:p>
           <a:p/>
           <a:p>
             <a:r>
-              <a:t>Claude Code CLI (run in terminal with the `claude` command):</a:t>
-            </a:r>
-          </a:p>
-          <a:p>
-            <a:r>
-              <a:t>• /compile-papers — core command; reads everything in /raw and creates wiki pages</a:t>
-            </a:r>
-          </a:p>
-          <a:p>
-            <a:r>
-              <a:t>• /sync-wiki — use when you add new papers; detects what's new, updates without clobbering existing content</a:t>
-            </a:r>
-          </a:p>
-          <a:p>
-            <a:r>
-              <a:t>• /audit-wiki — run every ~20 pages to catch quality issues</a:t>
-            </a:r>
-          </a:p>
-          <a:p>
-            <a:r>
-              <a:t>• /reset-wiki — for starting fresh with a new topic area</a:t>
-            </a:r>
-          </a:p>
-          <a:p>
-            <a:r>
-              <a:t>• /launch-wiki-ui — starts the Streamlit web app locally</a:t>
-            </a:r>
-          </a:p>
-          <a:p>
-            <a:r>
-              <a:t>• /stop-wiki-ui — stops the running Streamlit process</a:t>
-            </a:r>
-          </a:p>
-          <a:p>
-            <a:r>
-              <a:t>• /sync-docs — updates README, GitHub Pages, and sub-READMEs after code changes</a:t>
-            </a:r>
-          </a:p>
-          <a:p>
-            <a:r>
-              <a:t>• /run-maintenance — runs tests, verifies all skills registered, checks wiki and git health</a:t>
+              <a:t>WIKI SKILLS (orange = Claude / blue = Copilot) — the core wiki workflow:</a:t>
+            </a:r>
+          </a:p>
+          <a:p>
+            <a:r>
+              <a:t>• compile-papers — reads everything in /raw and creates wiki pages from scratch</a:t>
+            </a:r>
+          </a:p>
+          <a:p>
+            <a:r>
+              <a:t>• sync-wiki — use when you add new papers; detects what's new, updates without clobbering</a:t>
+            </a:r>
+          </a:p>
+          <a:p>
+            <a:r>
+              <a:t>• audit-wiki — run every ~20 pages to catch orphans, missing links, contradictions</a:t>
+            </a:r>
+          </a:p>
+          <a:p>
+            <a:r>
+              <a:t>• reset-wiki — wipe wiki for a fresh start with new topic area</a:t>
+            </a:r>
+          </a:p>
+          <a:p>
+            <a:r>
+              <a:t>• launch-wiki-ui — starts the Streamlit web app locally</a:t>
+            </a:r>
+          </a:p>
+          <a:p>
+            <a:r>
+              <a:t>• stop-wiki-ui — stops the running Streamlit process</a:t>
             </a:r>
           </a:p>
           <a:p/>
           <a:p>
             <a:r>
-              <a:t>GitHub Copilot Chat equivalents (identical commands, same skill files, different tool surface):</a:t>
-            </a:r>
-          </a:p>
-          <a:p>
-            <a:r>
-              <a:t>• /Compile Papers to Wiki, /Sync Wiki from Raw, /Audit Wiki, /Reset Wiki</a:t>
-            </a:r>
-          </a:p>
-          <a:p>
-            <a:r>
-              <a:t>• /Launch Wiki UI, /Stop Wiki UI, /Sync Docs, /Run Maintenance</a:t>
+              <a:t>REPO MAINTENANCE (purple, both tools) — separate from wiki operations:</a:t>
+            </a:r>
+          </a:p>
+          <a:p>
+            <a:r>
+              <a:t>• sync-docs — keeps README, GitHub Pages, and copilot-instructions in sync after code changes</a:t>
+            </a:r>
+          </a:p>
+          <a:p>
+            <a:r>
+              <a:t>• run-maintenance — full health check: runs tests, verifies skill registration, checks wiki + git state</a:t>
+            </a:r>
+          </a:p>
+          <a:p>
+            <a:r>
+              <a:t>• regenerate-presentation — rebuilds demo videos and this deck; detects changed scripts via git</a:t>
             </a:r>
           </a:p>
           <a:p/>
           <a:p>
             <a:r>
-              <a:t>The Streamlit Query UI is a secure web app where you can:</a:t>
-            </a:r>
-          </a:p>
-          <a:p>
-            <a:r>
-              <a:t>  • Enter your API key (never saved to disk — lives only in browser session memory)</a:t>
-            </a:r>
-          </a:p>
-          <a:p>
-            <a:r>
-              <a:t>  • Browse all wiki pages and see what's covered</a:t>
-            </a:r>
-          </a:p>
-          <a:p>
-            <a:r>
-              <a:t>  • Ask natural-language questions → Claude answers from wiki content only</a:t>
-            </a:r>
-          </a:p>
-          <a:p>
-            <a:r>
-              <a:t>  • Track token usage and cache performance</a:t>
+              <a:t>GitHub Copilot Chat equivalents (same skill files, natural language — no slash prefix):</a:t>
+            </a:r>
+          </a:p>
+          <a:p>
+            <a:r>
+              <a:t>• Compile Papers to Wiki, Sync Wiki from Raw, Audit Wiki, Reset Wiki, Launch Wiki UI, Stop Wiki UI</a:t>
+            </a:r>
+          </a:p>
+          <a:p>
+            <a:r>
+              <a:t>• Sync Docs, Run Maintenance, Regenerate Presentation</a:t>
             </a:r>
           </a:p>
           <a:p/>
           <a:p>
             <a:r>
-              <a:t>Crucially: if you ask about a topic not in the wiki, the UI returns an explicit "No information found" message with instructions to add sources. This is intentional — you always know the boundaries of your knowledge base.</a:t>
+              <a:t>The Streamlit Query UI is a multi-provider web app:</a:t>
+            </a:r>
+          </a:p>
+          <a:p>
+            <a:r>
+              <a:t>  • Supports Anthropic, OpenAI, Google, Mistral, Cohere — enter any model ID + API key</a:t>
+            </a:r>
+          </a:p>
+          <a:p>
+            <a:r>
+              <a:t>  • Answers grounded strictly in wiki content (no hallucination outside wiki)</a:t>
+            </a:r>
+          </a:p>
+          <a:p>
+            <a:r>
+              <a:t>  • API key lives only in browser session memory — never written to disk</a:t>
+            </a:r>
+          </a:p>
+          <a:p>
+            <a:r>
+              <a:t>  • Explicit "No information found" when a topic isn't in the wiki — you always know your boundaries</a:t>
             </a:r>
           </a:p>
           <a:p/>
@@ -1057,17 +1062,17 @@
           </a:p>
           <a:p>
             <a:r>
-              <a:t>  2. /compile-papers — scanning /raw, extracting concepts, creating 34 entity pages</a:t>
-            </a:r>
-          </a:p>
-          <a:p>
-            <a:r>
-              <a:t>  3. /sync-wiki — detecting a new file, updating existing pages, creating new ones</a:t>
-            </a:r>
-          </a:p>
-          <a:p>
-            <a:r>
-              <a:t>  4. /audit-wiki — finding 2 orphans, 3 missing pages, 1 contradiction</a:t>
+              <a:t>  2. /compile-papers — scanning 9 /raw sources, creating 37 entity pages</a:t>
+            </a:r>
+          </a:p>
+          <a:p>
+            <a:r>
+              <a:t>  3. /sync-wiki — all 9 sources already compiled; wiki is up to date</a:t>
+            </a:r>
+          </a:p>
+          <a:p>
+            <a:r>
+              <a:t>  4. /audit-wiki — 37 pages, 252 links resolved, 0 orphans, 0 missing, 0 contradictions</a:t>
             </a:r>
           </a:p>
           <a:p>
@@ -1114,7 +1119,7 @@
           </a:p>
           <a:p>
             <a:r>
-              <a:t>  • Terminal: minutes from raw papers to 34 interconnected wiki pages</a:t>
+              <a:t>  • Terminal: minutes from raw papers to 37 interconnected wiki pages</a:t>
             </a:r>
           </a:p>
           <a:p>
@@ -8057,7 +8062,7 @@
         <p:spPr>
           <a:xfrm>
             <a:off x="502920" y="1371600"/>
-            <a:ext cx="5257800" cy="4160520"/>
+            <a:ext cx="5230368" cy="4069080"/>
           </a:xfrm>
           <a:prstGeom prst="roundRect">
             <a:avLst/>
@@ -8102,7 +8107,7 @@
         <p:spPr>
           <a:xfrm>
             <a:off x="502920" y="1371600"/>
-            <a:ext cx="5257800" cy="64008"/>
+            <a:ext cx="5230368" cy="64008"/>
           </a:xfrm>
           <a:prstGeom prst="rect">
             <a:avLst/>
@@ -8144,8 +8149,8 @@
         </p:nvSpPr>
         <p:spPr>
           <a:xfrm>
-            <a:off x="502920" y="1463040"/>
-            <a:ext cx="5257800" cy="402336"/>
+            <a:off x="502920" y="1435608"/>
+            <a:ext cx="5230368" cy="329184"/>
           </a:xfrm>
           <a:prstGeom prst="rect">
             <a:avLst/>
@@ -8159,7 +8164,7 @@
           <a:lstStyle/>
           <a:p>
             <a:pPr algn="ctr">
-              <a:defRPr sz="1300" b="1">
+              <a:defRPr sz="1200" b="1">
                 <a:solidFill>
                   <a:srgbClr val="F59E0B"/>
                 </a:solidFill>
@@ -8180,8 +8185,8 @@
         </p:nvSpPr>
         <p:spPr>
           <a:xfrm>
-            <a:off x="685800" y="2029968"/>
-            <a:ext cx="1965960" cy="329184"/>
+            <a:off x="640080" y="1810512"/>
+            <a:ext cx="1828800" cy="182880"/>
           </a:xfrm>
           <a:prstGeom prst="rect">
             <a:avLst/>
@@ -8195,10 +8200,46 @@
           <a:lstStyle/>
           <a:p>
             <a:pPr algn="l">
-              <a:defRPr sz="1200" b="1">
+              <a:defRPr sz="900" b="1">
                 <a:solidFill>
                   <a:srgbClr val="F59E0B"/>
                 </a:solidFill>
+                <a:latin typeface="Calibri"/>
+              </a:defRPr>
+            </a:pPr>
+            <a:r>
+              <a:t>WIKI SKILLS</a:t>
+            </a:r>
+          </a:p>
+        </p:txBody>
+      </p:sp>
+      <p:sp>
+        <p:nvSpPr>
+          <p:cNvPr id="8" name="TextBox 7"/>
+          <p:cNvSpPr txBox="1"/>
+          <p:nvPr/>
+        </p:nvSpPr>
+        <p:spPr>
+          <a:xfrm>
+            <a:off x="640080" y="2002536"/>
+            <a:ext cx="1920240" cy="310896"/>
+          </a:xfrm>
+          <a:prstGeom prst="rect">
+            <a:avLst/>
+          </a:prstGeom>
+          <a:noFill/>
+        </p:spPr>
+        <p:txBody>
+          <a:bodyPr wrap="square">
+            <a:spAutoFit/>
+          </a:bodyPr>
+          <a:lstStyle/>
+          <a:p>
+            <a:pPr algn="l">
+              <a:defRPr sz="1000" b="1">
+                <a:solidFill>
+                  <a:srgbClr val="F59E0B"/>
+                </a:solidFill>
                 <a:latin typeface="Courier New"/>
               </a:defRPr>
             </a:pPr>
@@ -8210,14 +8251,14 @@
       </p:sp>
       <p:sp>
         <p:nvSpPr>
-          <p:cNvPr id="8" name="TextBox 7"/>
-          <p:cNvSpPr txBox="1"/>
-          <p:nvPr/>
-        </p:nvSpPr>
-        <p:spPr>
-          <a:xfrm>
-            <a:off x="2788920" y="2029968"/>
-            <a:ext cx="2697480" cy="329184"/>
+          <p:cNvPr id="9" name="TextBox 8"/>
+          <p:cNvSpPr txBox="1"/>
+          <p:nvPr/>
+        </p:nvSpPr>
+        <p:spPr>
+          <a:xfrm>
+            <a:off x="2679192" y="2002536"/>
+            <a:ext cx="2944368" cy="310896"/>
           </a:xfrm>
           <a:prstGeom prst="rect">
             <a:avLst/>
@@ -8231,7 +8272,7 @@
           <a:lstStyle/>
           <a:p>
             <a:pPr algn="l">
-              <a:defRPr sz="1100" b="0">
+              <a:defRPr sz="1000" b="0">
                 <a:solidFill>
                   <a:srgbClr val="C4D4EE"/>
                 </a:solidFill>
@@ -8246,14 +8287,14 @@
       </p:sp>
       <p:sp>
         <p:nvSpPr>
-          <p:cNvPr id="9" name="TextBox 8"/>
-          <p:cNvSpPr txBox="1"/>
-          <p:nvPr/>
-        </p:nvSpPr>
-        <p:spPr>
-          <a:xfrm>
-            <a:off x="685800" y="2468880"/>
-            <a:ext cx="1965960" cy="329184"/>
+          <p:cNvPr id="10" name="TextBox 9"/>
+          <p:cNvSpPr txBox="1"/>
+          <p:nvPr/>
+        </p:nvSpPr>
+        <p:spPr>
+          <a:xfrm>
+            <a:off x="640080" y="2340864"/>
+            <a:ext cx="1920240" cy="310896"/>
           </a:xfrm>
           <a:prstGeom prst="rect">
             <a:avLst/>
@@ -8267,7 +8308,7 @@
           <a:lstStyle/>
           <a:p>
             <a:pPr algn="l">
-              <a:defRPr sz="1200" b="1">
+              <a:defRPr sz="1000" b="1">
                 <a:solidFill>
                   <a:srgbClr val="F59E0B"/>
                 </a:solidFill>
@@ -8282,14 +8323,14 @@
       </p:sp>
       <p:sp>
         <p:nvSpPr>
-          <p:cNvPr id="10" name="TextBox 9"/>
-          <p:cNvSpPr txBox="1"/>
-          <p:nvPr/>
-        </p:nvSpPr>
-        <p:spPr>
-          <a:xfrm>
-            <a:off x="2788920" y="2468880"/>
-            <a:ext cx="2697480" cy="329184"/>
+          <p:cNvPr id="11" name="TextBox 10"/>
+          <p:cNvSpPr txBox="1"/>
+          <p:nvPr/>
+        </p:nvSpPr>
+        <p:spPr>
+          <a:xfrm>
+            <a:off x="2679192" y="2340864"/>
+            <a:ext cx="2944368" cy="310896"/>
           </a:xfrm>
           <a:prstGeom prst="rect">
             <a:avLst/>
@@ -8303,7 +8344,7 @@
           <a:lstStyle/>
           <a:p>
             <a:pPr algn="l">
-              <a:defRPr sz="1100" b="0">
+              <a:defRPr sz="1000" b="0">
                 <a:solidFill>
                   <a:srgbClr val="C4D4EE"/>
                 </a:solidFill>
@@ -8318,14 +8359,14 @@
       </p:sp>
       <p:sp>
         <p:nvSpPr>
-          <p:cNvPr id="11" name="TextBox 10"/>
-          <p:cNvSpPr txBox="1"/>
-          <p:nvPr/>
-        </p:nvSpPr>
-        <p:spPr>
-          <a:xfrm>
-            <a:off x="685800" y="2907792"/>
-            <a:ext cx="1965960" cy="329184"/>
+          <p:cNvPr id="12" name="TextBox 11"/>
+          <p:cNvSpPr txBox="1"/>
+          <p:nvPr/>
+        </p:nvSpPr>
+        <p:spPr>
+          <a:xfrm>
+            <a:off x="640080" y="2679192"/>
+            <a:ext cx="1920240" cy="310896"/>
           </a:xfrm>
           <a:prstGeom prst="rect">
             <a:avLst/>
@@ -8339,7 +8380,7 @@
           <a:lstStyle/>
           <a:p>
             <a:pPr algn="l">
-              <a:defRPr sz="1200" b="1">
+              <a:defRPr sz="1000" b="1">
                 <a:solidFill>
                   <a:srgbClr val="F59E0B"/>
                 </a:solidFill>
@@ -8354,14 +8395,14 @@
       </p:sp>
       <p:sp>
         <p:nvSpPr>
-          <p:cNvPr id="12" name="TextBox 11"/>
-          <p:cNvSpPr txBox="1"/>
-          <p:nvPr/>
-        </p:nvSpPr>
-        <p:spPr>
-          <a:xfrm>
-            <a:off x="2788920" y="2907792"/>
-            <a:ext cx="2697480" cy="329184"/>
+          <p:cNvPr id="13" name="TextBox 12"/>
+          <p:cNvSpPr txBox="1"/>
+          <p:nvPr/>
+        </p:nvSpPr>
+        <p:spPr>
+          <a:xfrm>
+            <a:off x="2679192" y="2679192"/>
+            <a:ext cx="2944368" cy="310896"/>
           </a:xfrm>
           <a:prstGeom prst="rect">
             <a:avLst/>
@@ -8375,7 +8416,7 @@
           <a:lstStyle/>
           <a:p>
             <a:pPr algn="l">
-              <a:defRPr sz="1100" b="0">
+              <a:defRPr sz="1000" b="0">
                 <a:solidFill>
                   <a:srgbClr val="C4D4EE"/>
                 </a:solidFill>
@@ -8390,14 +8431,14 @@
       </p:sp>
       <p:sp>
         <p:nvSpPr>
-          <p:cNvPr id="13" name="TextBox 12"/>
-          <p:cNvSpPr txBox="1"/>
-          <p:nvPr/>
-        </p:nvSpPr>
-        <p:spPr>
-          <a:xfrm>
-            <a:off x="685800" y="3346704"/>
-            <a:ext cx="1965960" cy="329184"/>
+          <p:cNvPr id="14" name="TextBox 13"/>
+          <p:cNvSpPr txBox="1"/>
+          <p:nvPr/>
+        </p:nvSpPr>
+        <p:spPr>
+          <a:xfrm>
+            <a:off x="640080" y="3017520"/>
+            <a:ext cx="1920240" cy="310896"/>
           </a:xfrm>
           <a:prstGeom prst="rect">
             <a:avLst/>
@@ -8411,7 +8452,7 @@
           <a:lstStyle/>
           <a:p>
             <a:pPr algn="l">
-              <a:defRPr sz="1200" b="1">
+              <a:defRPr sz="1000" b="1">
                 <a:solidFill>
                   <a:srgbClr val="F59E0B"/>
                 </a:solidFill>
@@ -8426,14 +8467,14 @@
       </p:sp>
       <p:sp>
         <p:nvSpPr>
-          <p:cNvPr id="14" name="TextBox 13"/>
-          <p:cNvSpPr txBox="1"/>
-          <p:nvPr/>
-        </p:nvSpPr>
-        <p:spPr>
-          <a:xfrm>
-            <a:off x="2788920" y="3346704"/>
-            <a:ext cx="2697480" cy="329184"/>
+          <p:cNvPr id="15" name="TextBox 14"/>
+          <p:cNvSpPr txBox="1"/>
+          <p:nvPr/>
+        </p:nvSpPr>
+        <p:spPr>
+          <a:xfrm>
+            <a:off x="2679192" y="3017520"/>
+            <a:ext cx="2944368" cy="310896"/>
           </a:xfrm>
           <a:prstGeom prst="rect">
             <a:avLst/>
@@ -8447,7 +8488,7 @@
           <a:lstStyle/>
           <a:p>
             <a:pPr algn="l">
-              <a:defRPr sz="1100" b="0">
+              <a:defRPr sz="1000" b="0">
                 <a:solidFill>
                   <a:srgbClr val="C4D4EE"/>
                 </a:solidFill>
@@ -8462,14 +8503,14 @@
       </p:sp>
       <p:sp>
         <p:nvSpPr>
-          <p:cNvPr id="15" name="TextBox 14"/>
-          <p:cNvSpPr txBox="1"/>
-          <p:nvPr/>
-        </p:nvSpPr>
-        <p:spPr>
-          <a:xfrm>
-            <a:off x="685800" y="3785616"/>
-            <a:ext cx="1965960" cy="329184"/>
+          <p:cNvPr id="16" name="TextBox 15"/>
+          <p:cNvSpPr txBox="1"/>
+          <p:nvPr/>
+        </p:nvSpPr>
+        <p:spPr>
+          <a:xfrm>
+            <a:off x="640080" y="3355848"/>
+            <a:ext cx="1920240" cy="310896"/>
           </a:xfrm>
           <a:prstGeom prst="rect">
             <a:avLst/>
@@ -8483,7 +8524,7 @@
           <a:lstStyle/>
           <a:p>
             <a:pPr algn="l">
-              <a:defRPr sz="1200" b="1">
+              <a:defRPr sz="1000" b="1">
                 <a:solidFill>
                   <a:srgbClr val="F59E0B"/>
                 </a:solidFill>
@@ -8498,14 +8539,14 @@
       </p:sp>
       <p:sp>
         <p:nvSpPr>
-          <p:cNvPr id="16" name="TextBox 15"/>
-          <p:cNvSpPr txBox="1"/>
-          <p:nvPr/>
-        </p:nvSpPr>
-        <p:spPr>
-          <a:xfrm>
-            <a:off x="2788920" y="3785616"/>
-            <a:ext cx="2697480" cy="329184"/>
+          <p:cNvPr id="17" name="TextBox 16"/>
+          <p:cNvSpPr txBox="1"/>
+          <p:nvPr/>
+        </p:nvSpPr>
+        <p:spPr>
+          <a:xfrm>
+            <a:off x="2679192" y="3355848"/>
+            <a:ext cx="2944368" cy="310896"/>
           </a:xfrm>
           <a:prstGeom prst="rect">
             <a:avLst/>
@@ -8519,7 +8560,7 @@
           <a:lstStyle/>
           <a:p>
             <a:pPr algn="l">
-              <a:defRPr sz="1100" b="0">
+              <a:defRPr sz="1000" b="0">
                 <a:solidFill>
                   <a:srgbClr val="C4D4EE"/>
                 </a:solidFill>
@@ -8534,14 +8575,14 @@
       </p:sp>
       <p:sp>
         <p:nvSpPr>
-          <p:cNvPr id="17" name="TextBox 16"/>
-          <p:cNvSpPr txBox="1"/>
-          <p:nvPr/>
-        </p:nvSpPr>
-        <p:spPr>
-          <a:xfrm>
-            <a:off x="685800" y="4224528"/>
-            <a:ext cx="1965960" cy="329184"/>
+          <p:cNvPr id="18" name="TextBox 17"/>
+          <p:cNvSpPr txBox="1"/>
+          <p:nvPr/>
+        </p:nvSpPr>
+        <p:spPr>
+          <a:xfrm>
+            <a:off x="640080" y="3694176"/>
+            <a:ext cx="1920240" cy="310896"/>
           </a:xfrm>
           <a:prstGeom prst="rect">
             <a:avLst/>
@@ -8555,7 +8596,7 @@
           <a:lstStyle/>
           <a:p>
             <a:pPr algn="l">
-              <a:defRPr sz="1200" b="1">
+              <a:defRPr sz="1000" b="1">
                 <a:solidFill>
                   <a:srgbClr val="F59E0B"/>
                 </a:solidFill>
@@ -8570,14 +8611,14 @@
       </p:sp>
       <p:sp>
         <p:nvSpPr>
-          <p:cNvPr id="18" name="TextBox 17"/>
-          <p:cNvSpPr txBox="1"/>
-          <p:nvPr/>
-        </p:nvSpPr>
-        <p:spPr>
-          <a:xfrm>
-            <a:off x="2788920" y="4224528"/>
-            <a:ext cx="2697480" cy="329184"/>
+          <p:cNvPr id="19" name="TextBox 18"/>
+          <p:cNvSpPr txBox="1"/>
+          <p:nvPr/>
+        </p:nvSpPr>
+        <p:spPr>
+          <a:xfrm>
+            <a:off x="2679192" y="3694176"/>
+            <a:ext cx="2944368" cy="310896"/>
           </a:xfrm>
           <a:prstGeom prst="rect">
             <a:avLst/>
@@ -8591,7 +8632,7 @@
           <a:lstStyle/>
           <a:p>
             <a:pPr algn="l">
-              <a:defRPr sz="1100" b="0">
+              <a:defRPr sz="1000" b="0">
                 <a:solidFill>
                   <a:srgbClr val="C4D4EE"/>
                 </a:solidFill>
@@ -8606,14 +8647,57 @@
       </p:sp>
       <p:sp>
         <p:nvSpPr>
-          <p:cNvPr id="19" name="TextBox 18"/>
-          <p:cNvSpPr txBox="1"/>
-          <p:nvPr/>
-        </p:nvSpPr>
-        <p:spPr>
-          <a:xfrm>
-            <a:off x="685800" y="4663440"/>
-            <a:ext cx="1965960" cy="329184"/>
+          <p:cNvPr id="20" name="Rectangle 19"/>
+          <p:cNvSpPr/>
+          <p:nvPr/>
+        </p:nvSpPr>
+        <p:spPr>
+          <a:xfrm>
+            <a:off x="640080" y="4069080"/>
+            <a:ext cx="4956048" cy="12700"/>
+          </a:xfrm>
+          <a:prstGeom prst="rect">
+            <a:avLst/>
+          </a:prstGeom>
+          <a:solidFill>
+            <a:srgbClr val="233764"/>
+          </a:solidFill>
+          <a:ln>
+            <a:noFill/>
+          </a:ln>
+        </p:spPr>
+        <p:style>
+          <a:lnRef idx="1">
+            <a:schemeClr val="accent1"/>
+          </a:lnRef>
+          <a:fillRef idx="3">
+            <a:schemeClr val="accent1"/>
+          </a:fillRef>
+          <a:effectRef idx="2">
+            <a:schemeClr val="accent1"/>
+          </a:effectRef>
+          <a:fontRef idx="minor">
+            <a:schemeClr val="lt1"/>
+          </a:fontRef>
+        </p:style>
+        <p:txBody>
+          <a:bodyPr rtlCol="0" anchor="ctr"/>
+          <a:lstStyle/>
+          <a:p>
+            <a:pPr algn="ctr"/>
+          </a:p>
+        </p:txBody>
+      </p:sp>
+      <p:sp>
+        <p:nvSpPr>
+          <p:cNvPr id="21" name="TextBox 20"/>
+          <p:cNvSpPr txBox="1"/>
+          <p:nvPr/>
+        </p:nvSpPr>
+        <p:spPr>
+          <a:xfrm>
+            <a:off x="640080" y="4142232"/>
+            <a:ext cx="2011680" cy="182880"/>
           </a:xfrm>
           <a:prstGeom prst="rect">
             <a:avLst/>
@@ -8627,9 +8711,45 @@
           <a:lstStyle/>
           <a:p>
             <a:pPr algn="l">
-              <a:defRPr sz="1200" b="1">
-                <a:solidFill>
-                  <a:srgbClr val="F59E0B"/>
+              <a:defRPr sz="900" b="1">
+                <a:solidFill>
+                  <a:srgbClr val="8B5CF6"/>
+                </a:solidFill>
+                <a:latin typeface="Calibri"/>
+              </a:defRPr>
+            </a:pPr>
+            <a:r>
+              <a:t>REPO MAINTENANCE</a:t>
+            </a:r>
+          </a:p>
+        </p:txBody>
+      </p:sp>
+      <p:sp>
+        <p:nvSpPr>
+          <p:cNvPr id="22" name="TextBox 21"/>
+          <p:cNvSpPr txBox="1"/>
+          <p:nvPr/>
+        </p:nvSpPr>
+        <p:spPr>
+          <a:xfrm>
+            <a:off x="640080" y="4343400"/>
+            <a:ext cx="1920240" cy="310896"/>
+          </a:xfrm>
+          <a:prstGeom prst="rect">
+            <a:avLst/>
+          </a:prstGeom>
+          <a:noFill/>
+        </p:spPr>
+        <p:txBody>
+          <a:bodyPr wrap="square">
+            <a:spAutoFit/>
+          </a:bodyPr>
+          <a:lstStyle/>
+          <a:p>
+            <a:pPr algn="l">
+              <a:defRPr sz="1000" b="1">
+                <a:solidFill>
+                  <a:srgbClr val="8B5CF6"/>
                 </a:solidFill>
                 <a:latin typeface="Courier New"/>
               </a:defRPr>
@@ -8642,14 +8762,14 @@
       </p:sp>
       <p:sp>
         <p:nvSpPr>
-          <p:cNvPr id="20" name="TextBox 19"/>
-          <p:cNvSpPr txBox="1"/>
-          <p:nvPr/>
-        </p:nvSpPr>
-        <p:spPr>
-          <a:xfrm>
-            <a:off x="2788920" y="4663440"/>
-            <a:ext cx="2697480" cy="329184"/>
+          <p:cNvPr id="23" name="TextBox 22"/>
+          <p:cNvSpPr txBox="1"/>
+          <p:nvPr/>
+        </p:nvSpPr>
+        <p:spPr>
+          <a:xfrm>
+            <a:off x="2679192" y="4343400"/>
+            <a:ext cx="2944368" cy="310896"/>
           </a:xfrm>
           <a:prstGeom prst="rect">
             <a:avLst/>
@@ -8663,7 +8783,7 @@
           <a:lstStyle/>
           <a:p>
             <a:pPr algn="l">
-              <a:defRPr sz="1100" b="0">
+              <a:defRPr sz="1000" b="0">
                 <a:solidFill>
                   <a:srgbClr val="C4D4EE"/>
                 </a:solidFill>
@@ -8671,21 +8791,21 @@
               </a:defRPr>
             </a:pPr>
             <a:r>
-              <a:t>Update README, GitHub Pages, sub-READMEs</a:t>
-            </a:r>
-          </a:p>
-        </p:txBody>
-      </p:sp>
-      <p:sp>
-        <p:nvSpPr>
-          <p:cNvPr id="21" name="TextBox 20"/>
-          <p:cNvSpPr txBox="1"/>
-          <p:nvPr/>
-        </p:nvSpPr>
-        <p:spPr>
-          <a:xfrm>
-            <a:off x="685800" y="5102352"/>
-            <a:ext cx="1965960" cy="329184"/>
+              <a:t>Sync README, GitHub Pages, sub-READMEs</a:t>
+            </a:r>
+          </a:p>
+        </p:txBody>
+      </p:sp>
+      <p:sp>
+        <p:nvSpPr>
+          <p:cNvPr id="24" name="TextBox 23"/>
+          <p:cNvSpPr txBox="1"/>
+          <p:nvPr/>
+        </p:nvSpPr>
+        <p:spPr>
+          <a:xfrm>
+            <a:off x="640080" y="4681728"/>
+            <a:ext cx="1920240" cy="310896"/>
           </a:xfrm>
           <a:prstGeom prst="rect">
             <a:avLst/>
@@ -8699,9 +8819,9 @@
           <a:lstStyle/>
           <a:p>
             <a:pPr algn="l">
-              <a:defRPr sz="1200" b="1">
-                <a:solidFill>
-                  <a:srgbClr val="F59E0B"/>
+              <a:defRPr sz="1000" b="1">
+                <a:solidFill>
+                  <a:srgbClr val="8B5CF6"/>
                 </a:solidFill>
                 <a:latin typeface="Courier New"/>
               </a:defRPr>
@@ -8714,14 +8834,14 @@
       </p:sp>
       <p:sp>
         <p:nvSpPr>
-          <p:cNvPr id="22" name="TextBox 21"/>
-          <p:cNvSpPr txBox="1"/>
-          <p:nvPr/>
-        </p:nvSpPr>
-        <p:spPr>
-          <a:xfrm>
-            <a:off x="2788920" y="5102352"/>
-            <a:ext cx="2697480" cy="329184"/>
+          <p:cNvPr id="25" name="TextBox 24"/>
+          <p:cNvSpPr txBox="1"/>
+          <p:nvPr/>
+        </p:nvSpPr>
+        <p:spPr>
+          <a:xfrm>
+            <a:off x="2679192" y="4681728"/>
+            <a:ext cx="2944368" cy="310896"/>
           </a:xfrm>
           <a:prstGeom prst="rect">
             <a:avLst/>
@@ -8735,7 +8855,7 @@
           <a:lstStyle/>
           <a:p>
             <a:pPr algn="l">
-              <a:defRPr sz="1100" b="0">
+              <a:defRPr sz="1000" b="0">
                 <a:solidFill>
                   <a:srgbClr val="C4D4EE"/>
                 </a:solidFill>
@@ -8743,21 +8863,93 @@
               </a:defRPr>
             </a:pPr>
             <a:r>
-              <a:t>Run tests, verify skills, check git health</a:t>
-            </a:r>
-          </a:p>
-        </p:txBody>
-      </p:sp>
-      <p:sp>
-        <p:nvSpPr>
-          <p:cNvPr id="23" name="Rounded Rectangle 22"/>
+              <a:t>Run tests, verify skills, git health</a:t>
+            </a:r>
+          </a:p>
+        </p:txBody>
+      </p:sp>
+      <p:sp>
+        <p:nvSpPr>
+          <p:cNvPr id="26" name="TextBox 25"/>
+          <p:cNvSpPr txBox="1"/>
+          <p:nvPr/>
+        </p:nvSpPr>
+        <p:spPr>
+          <a:xfrm>
+            <a:off x="640080" y="5020056"/>
+            <a:ext cx="1920240" cy="310896"/>
+          </a:xfrm>
+          <a:prstGeom prst="rect">
+            <a:avLst/>
+          </a:prstGeom>
+          <a:noFill/>
+        </p:spPr>
+        <p:txBody>
+          <a:bodyPr wrap="square">
+            <a:spAutoFit/>
+          </a:bodyPr>
+          <a:lstStyle/>
+          <a:p>
+            <a:pPr algn="l">
+              <a:defRPr sz="1000" b="1">
+                <a:solidFill>
+                  <a:srgbClr val="8B5CF6"/>
+                </a:solidFill>
+                <a:latin typeface="Courier New"/>
+              </a:defRPr>
+            </a:pPr>
+            <a:r>
+              <a:t>/regenerate-presentation</a:t>
+            </a:r>
+          </a:p>
+        </p:txBody>
+      </p:sp>
+      <p:sp>
+        <p:nvSpPr>
+          <p:cNvPr id="27" name="TextBox 26"/>
+          <p:cNvSpPr txBox="1"/>
+          <p:nvPr/>
+        </p:nvSpPr>
+        <p:spPr>
+          <a:xfrm>
+            <a:off x="2679192" y="5020056"/>
+            <a:ext cx="2944368" cy="310896"/>
+          </a:xfrm>
+          <a:prstGeom prst="rect">
+            <a:avLst/>
+          </a:prstGeom>
+          <a:noFill/>
+        </p:spPr>
+        <p:txBody>
+          <a:bodyPr wrap="square">
+            <a:spAutoFit/>
+          </a:bodyPr>
+          <a:lstStyle/>
+          <a:p>
+            <a:pPr algn="l">
+              <a:defRPr sz="1000" b="0">
+                <a:solidFill>
+                  <a:srgbClr val="C4D4EE"/>
+                </a:solidFill>
+                <a:latin typeface="Calibri"/>
+              </a:defRPr>
+            </a:pPr>
+            <a:r>
+              <a:t>Rebuild demo videos and PPTX deck</a:t>
+            </a:r>
+          </a:p>
+        </p:txBody>
+      </p:sp>
+      <p:sp>
+        <p:nvSpPr>
+          <p:cNvPr id="28" name="Rounded Rectangle 27"/>
           <p:cNvSpPr/>
           <p:nvPr/>
         </p:nvSpPr>
         <p:spPr>
           <a:xfrm>
             <a:off x="6400800" y="1371600"/>
-            <a:ext cx="5257800" cy="4160520"/>
+            <a:ext cx="5230368" cy="4069080"/>
           </a:xfrm>
           <a:prstGeom prst="roundRect">
             <a:avLst/>
@@ -8795,14 +8987,14 @@
       </p:sp>
       <p:sp>
         <p:nvSpPr>
-          <p:cNvPr id="24" name="Rectangle 23"/>
+          <p:cNvPr id="29" name="Rectangle 28"/>
           <p:cNvSpPr/>
           <p:nvPr/>
         </p:nvSpPr>
         <p:spPr>
           <a:xfrm>
             <a:off x="6400800" y="1371600"/>
-            <a:ext cx="5257800" cy="64008"/>
+            <a:ext cx="5230368" cy="64008"/>
           </a:xfrm>
           <a:prstGeom prst="rect">
             <a:avLst/>
@@ -8838,14 +9030,14 @@
       </p:sp>
       <p:sp>
         <p:nvSpPr>
-          <p:cNvPr id="25" name="TextBox 24"/>
-          <p:cNvSpPr txBox="1"/>
-          <p:nvPr/>
-        </p:nvSpPr>
-        <p:spPr>
-          <a:xfrm>
-            <a:off x="6400800" y="1463040"/>
-            <a:ext cx="5257800" cy="402336"/>
+          <p:cNvPr id="30" name="TextBox 29"/>
+          <p:cNvSpPr txBox="1"/>
+          <p:nvPr/>
+        </p:nvSpPr>
+        <p:spPr>
+          <a:xfrm>
+            <a:off x="6400800" y="1435608"/>
+            <a:ext cx="5230368" cy="329184"/>
           </a:xfrm>
           <a:prstGeom prst="rect">
             <a:avLst/>
@@ -8859,7 +9051,7 @@
           <a:lstStyle/>
           <a:p>
             <a:pPr algn="ctr">
-              <a:defRPr sz="1300" b="1">
+              <a:defRPr sz="1200" b="1">
                 <a:solidFill>
                   <a:srgbClr val="3B82F6"/>
                 </a:solidFill>
@@ -8874,14 +9066,14 @@
       </p:sp>
       <p:sp>
         <p:nvSpPr>
-          <p:cNvPr id="26" name="TextBox 25"/>
-          <p:cNvSpPr txBox="1"/>
-          <p:nvPr/>
-        </p:nvSpPr>
-        <p:spPr>
-          <a:xfrm>
-            <a:off x="6583680" y="2029968"/>
-            <a:ext cx="2468880" cy="329184"/>
+          <p:cNvPr id="31" name="TextBox 30"/>
+          <p:cNvSpPr txBox="1"/>
+          <p:nvPr/>
+        </p:nvSpPr>
+        <p:spPr>
+          <a:xfrm>
+            <a:off x="6537960" y="1810512"/>
+            <a:ext cx="1828800" cy="182880"/>
           </a:xfrm>
           <a:prstGeom prst="rect">
             <a:avLst/>
@@ -8895,29 +9087,65 @@
           <a:lstStyle/>
           <a:p>
             <a:pPr algn="l">
-              <a:defRPr sz="1200" b="1">
+              <a:defRPr sz="900" b="1">
                 <a:solidFill>
                   <a:srgbClr val="3B82F6"/>
                 </a:solidFill>
+                <a:latin typeface="Calibri"/>
+              </a:defRPr>
+            </a:pPr>
+            <a:r>
+              <a:t>WIKI SKILLS</a:t>
+            </a:r>
+          </a:p>
+        </p:txBody>
+      </p:sp>
+      <p:sp>
+        <p:nvSpPr>
+          <p:cNvPr id="32" name="TextBox 31"/>
+          <p:cNvSpPr txBox="1"/>
+          <p:nvPr/>
+        </p:nvSpPr>
+        <p:spPr>
+          <a:xfrm>
+            <a:off x="6537960" y="2002536"/>
+            <a:ext cx="2103120" cy="310896"/>
+          </a:xfrm>
+          <a:prstGeom prst="rect">
+            <a:avLst/>
+          </a:prstGeom>
+          <a:noFill/>
+        </p:spPr>
+        <p:txBody>
+          <a:bodyPr wrap="square">
+            <a:spAutoFit/>
+          </a:bodyPr>
+          <a:lstStyle/>
+          <a:p>
+            <a:pPr algn="l">
+              <a:defRPr sz="1000" b="1">
+                <a:solidFill>
+                  <a:srgbClr val="3B82F6"/>
+                </a:solidFill>
                 <a:latin typeface="Courier New"/>
               </a:defRPr>
             </a:pPr>
             <a:r>
-              <a:t>/Compile Papers to Wiki</a:t>
-            </a:r>
-          </a:p>
-        </p:txBody>
-      </p:sp>
-      <p:sp>
-        <p:nvSpPr>
-          <p:cNvPr id="27" name="TextBox 26"/>
-          <p:cNvSpPr txBox="1"/>
-          <p:nvPr/>
-        </p:nvSpPr>
-        <p:spPr>
-          <a:xfrm>
-            <a:off x="9144000" y="2029968"/>
-            <a:ext cx="2377440" cy="329184"/>
+              <a:t>Compile Papers to Wiki</a:t>
+            </a:r>
+          </a:p>
+        </p:txBody>
+      </p:sp>
+      <p:sp>
+        <p:nvSpPr>
+          <p:cNvPr id="33" name="TextBox 32"/>
+          <p:cNvSpPr txBox="1"/>
+          <p:nvPr/>
+        </p:nvSpPr>
+        <p:spPr>
+          <a:xfrm>
+            <a:off x="8759952" y="2002536"/>
+            <a:ext cx="2761488" cy="310896"/>
           </a:xfrm>
           <a:prstGeom prst="rect">
             <a:avLst/>
@@ -8931,7 +9159,7 @@
           <a:lstStyle/>
           <a:p>
             <a:pPr algn="l">
-              <a:defRPr sz="1100" b="0">
+              <a:defRPr sz="1000" b="0">
                 <a:solidFill>
                   <a:srgbClr val="C4D4EE"/>
                 </a:solidFill>
@@ -8946,14 +9174,14 @@
       </p:sp>
       <p:sp>
         <p:nvSpPr>
-          <p:cNvPr id="28" name="TextBox 27"/>
-          <p:cNvSpPr txBox="1"/>
-          <p:nvPr/>
-        </p:nvSpPr>
-        <p:spPr>
-          <a:xfrm>
-            <a:off x="6583680" y="2468880"/>
-            <a:ext cx="2468880" cy="329184"/>
+          <p:cNvPr id="34" name="TextBox 33"/>
+          <p:cNvSpPr txBox="1"/>
+          <p:nvPr/>
+        </p:nvSpPr>
+        <p:spPr>
+          <a:xfrm>
+            <a:off x="6537960" y="2340864"/>
+            <a:ext cx="2103120" cy="310896"/>
           </a:xfrm>
           <a:prstGeom prst="rect">
             <a:avLst/>
@@ -8967,7 +9195,7 @@
           <a:lstStyle/>
           <a:p>
             <a:pPr algn="l">
-              <a:defRPr sz="1200" b="1">
+              <a:defRPr sz="1000" b="1">
                 <a:solidFill>
                   <a:srgbClr val="3B82F6"/>
                 </a:solidFill>
@@ -8975,21 +9203,21 @@
               </a:defRPr>
             </a:pPr>
             <a:r>
-              <a:t>/Sync Wiki from Raw</a:t>
-            </a:r>
-          </a:p>
-        </p:txBody>
-      </p:sp>
-      <p:sp>
-        <p:nvSpPr>
-          <p:cNvPr id="29" name="TextBox 28"/>
-          <p:cNvSpPr txBox="1"/>
-          <p:nvPr/>
-        </p:nvSpPr>
-        <p:spPr>
-          <a:xfrm>
-            <a:off x="9144000" y="2468880"/>
-            <a:ext cx="2377440" cy="329184"/>
+              <a:t>Sync Wiki from Raw</a:t>
+            </a:r>
+          </a:p>
+        </p:txBody>
+      </p:sp>
+      <p:sp>
+        <p:nvSpPr>
+          <p:cNvPr id="35" name="TextBox 34"/>
+          <p:cNvSpPr txBox="1"/>
+          <p:nvPr/>
+        </p:nvSpPr>
+        <p:spPr>
+          <a:xfrm>
+            <a:off x="8759952" y="2340864"/>
+            <a:ext cx="2761488" cy="310896"/>
           </a:xfrm>
           <a:prstGeom prst="rect">
             <a:avLst/>
@@ -9003,7 +9231,7 @@
           <a:lstStyle/>
           <a:p>
             <a:pPr algn="l">
-              <a:defRPr sz="1100" b="0">
+              <a:defRPr sz="1000" b="0">
                 <a:solidFill>
                   <a:srgbClr val="C4D4EE"/>
                 </a:solidFill>
@@ -9011,21 +9239,21 @@
               </a:defRPr>
             </a:pPr>
             <a:r>
-              <a:t>Incremental update</a:t>
-            </a:r>
-          </a:p>
-        </p:txBody>
-      </p:sp>
-      <p:sp>
-        <p:nvSpPr>
-          <p:cNvPr id="30" name="TextBox 29"/>
-          <p:cNvSpPr txBox="1"/>
-          <p:nvPr/>
-        </p:nvSpPr>
-        <p:spPr>
-          <a:xfrm>
-            <a:off x="6583680" y="2907792"/>
-            <a:ext cx="2468880" cy="329184"/>
+              <a:t>Incremental update from new sources</a:t>
+            </a:r>
+          </a:p>
+        </p:txBody>
+      </p:sp>
+      <p:sp>
+        <p:nvSpPr>
+          <p:cNvPr id="36" name="TextBox 35"/>
+          <p:cNvSpPr txBox="1"/>
+          <p:nvPr/>
+        </p:nvSpPr>
+        <p:spPr>
+          <a:xfrm>
+            <a:off x="6537960" y="2679192"/>
+            <a:ext cx="2103120" cy="310896"/>
           </a:xfrm>
           <a:prstGeom prst="rect">
             <a:avLst/>
@@ -9039,7 +9267,7 @@
           <a:lstStyle/>
           <a:p>
             <a:pPr algn="l">
-              <a:defRPr sz="1200" b="1">
+              <a:defRPr sz="1000" b="1">
                 <a:solidFill>
                   <a:srgbClr val="3B82F6"/>
                 </a:solidFill>
@@ -9047,21 +9275,21 @@
               </a:defRPr>
             </a:pPr>
             <a:r>
-              <a:t>/Audit Wiki</a:t>
-            </a:r>
-          </a:p>
-        </p:txBody>
-      </p:sp>
-      <p:sp>
-        <p:nvSpPr>
-          <p:cNvPr id="31" name="TextBox 30"/>
-          <p:cNvSpPr txBox="1"/>
-          <p:nvPr/>
-        </p:nvSpPr>
-        <p:spPr>
-          <a:xfrm>
-            <a:off x="9144000" y="2907792"/>
-            <a:ext cx="2377440" cy="329184"/>
+              <a:t>Audit Wiki</a:t>
+            </a:r>
+          </a:p>
+        </p:txBody>
+      </p:sp>
+      <p:sp>
+        <p:nvSpPr>
+          <p:cNvPr id="37" name="TextBox 36"/>
+          <p:cNvSpPr txBox="1"/>
+          <p:nvPr/>
+        </p:nvSpPr>
+        <p:spPr>
+          <a:xfrm>
+            <a:off x="8759952" y="2679192"/>
+            <a:ext cx="2761488" cy="310896"/>
           </a:xfrm>
           <a:prstGeom prst="rect">
             <a:avLst/>
@@ -9075,7 +9303,7 @@
           <a:lstStyle/>
           <a:p>
             <a:pPr algn="l">
-              <a:defRPr sz="1100" b="0">
+              <a:defRPr sz="1000" b="0">
                 <a:solidFill>
                   <a:srgbClr val="C4D4EE"/>
                 </a:solidFill>
@@ -9083,21 +9311,21 @@
               </a:defRPr>
             </a:pPr>
             <a:r>
-              <a:t>Quality check</a:t>
-            </a:r>
-          </a:p>
-        </p:txBody>
-      </p:sp>
-      <p:sp>
-        <p:nvSpPr>
-          <p:cNvPr id="32" name="TextBox 31"/>
-          <p:cNvSpPr txBox="1"/>
-          <p:nvPr/>
-        </p:nvSpPr>
-        <p:spPr>
-          <a:xfrm>
-            <a:off x="6583680" y="3346704"/>
-            <a:ext cx="2468880" cy="329184"/>
+              <a:t>Quality check — orphans, contradictions</a:t>
+            </a:r>
+          </a:p>
+        </p:txBody>
+      </p:sp>
+      <p:sp>
+        <p:nvSpPr>
+          <p:cNvPr id="38" name="TextBox 37"/>
+          <p:cNvSpPr txBox="1"/>
+          <p:nvPr/>
+        </p:nvSpPr>
+        <p:spPr>
+          <a:xfrm>
+            <a:off x="6537960" y="3017520"/>
+            <a:ext cx="2103120" cy="310896"/>
           </a:xfrm>
           <a:prstGeom prst="rect">
             <a:avLst/>
@@ -9111,7 +9339,7 @@
           <a:lstStyle/>
           <a:p>
             <a:pPr algn="l">
-              <a:defRPr sz="1200" b="1">
+              <a:defRPr sz="1000" b="1">
                 <a:solidFill>
                   <a:srgbClr val="3B82F6"/>
                 </a:solidFill>
@@ -9119,21 +9347,21 @@
               </a:defRPr>
             </a:pPr>
             <a:r>
-              <a:t>/Reset Wiki</a:t>
-            </a:r>
-          </a:p>
-        </p:txBody>
-      </p:sp>
-      <p:sp>
-        <p:nvSpPr>
-          <p:cNvPr id="33" name="TextBox 32"/>
-          <p:cNvSpPr txBox="1"/>
-          <p:nvPr/>
-        </p:nvSpPr>
-        <p:spPr>
-          <a:xfrm>
-            <a:off x="9144000" y="3346704"/>
-            <a:ext cx="2377440" cy="329184"/>
+              <a:t>Reset Wiki</a:t>
+            </a:r>
+          </a:p>
+        </p:txBody>
+      </p:sp>
+      <p:sp>
+        <p:nvSpPr>
+          <p:cNvPr id="39" name="TextBox 38"/>
+          <p:cNvSpPr txBox="1"/>
+          <p:nvPr/>
+        </p:nvSpPr>
+        <p:spPr>
+          <a:xfrm>
+            <a:off x="8759952" y="3017520"/>
+            <a:ext cx="2761488" cy="310896"/>
           </a:xfrm>
           <a:prstGeom prst="rect">
             <a:avLst/>
@@ -9147,7 +9375,7 @@
           <a:lstStyle/>
           <a:p>
             <a:pPr algn="l">
-              <a:defRPr sz="1100" b="0">
+              <a:defRPr sz="1000" b="0">
                 <a:solidFill>
                   <a:srgbClr val="C4D4EE"/>
                 </a:solidFill>
@@ -9162,14 +9390,14 @@
       </p:sp>
       <p:sp>
         <p:nvSpPr>
-          <p:cNvPr id="34" name="TextBox 33"/>
-          <p:cNvSpPr txBox="1"/>
-          <p:nvPr/>
-        </p:nvSpPr>
-        <p:spPr>
-          <a:xfrm>
-            <a:off x="6583680" y="3785616"/>
-            <a:ext cx="2468880" cy="329184"/>
+          <p:cNvPr id="40" name="TextBox 39"/>
+          <p:cNvSpPr txBox="1"/>
+          <p:nvPr/>
+        </p:nvSpPr>
+        <p:spPr>
+          <a:xfrm>
+            <a:off x="6537960" y="3355848"/>
+            <a:ext cx="2103120" cy="310896"/>
           </a:xfrm>
           <a:prstGeom prst="rect">
             <a:avLst/>
@@ -9183,7 +9411,7 @@
           <a:lstStyle/>
           <a:p>
             <a:pPr algn="l">
-              <a:defRPr sz="1200" b="1">
+              <a:defRPr sz="1000" b="1">
                 <a:solidFill>
                   <a:srgbClr val="3B82F6"/>
                 </a:solidFill>
@@ -9191,21 +9419,21 @@
               </a:defRPr>
             </a:pPr>
             <a:r>
-              <a:t>/Launch Wiki UI</a:t>
-            </a:r>
-          </a:p>
-        </p:txBody>
-      </p:sp>
-      <p:sp>
-        <p:nvSpPr>
-          <p:cNvPr id="35" name="TextBox 34"/>
-          <p:cNvSpPr txBox="1"/>
-          <p:nvPr/>
-        </p:nvSpPr>
-        <p:spPr>
-          <a:xfrm>
-            <a:off x="9144000" y="3785616"/>
-            <a:ext cx="2377440" cy="329184"/>
+              <a:t>Launch Wiki UI</a:t>
+            </a:r>
+          </a:p>
+        </p:txBody>
+      </p:sp>
+      <p:sp>
+        <p:nvSpPr>
+          <p:cNvPr id="41" name="TextBox 40"/>
+          <p:cNvSpPr txBox="1"/>
+          <p:nvPr/>
+        </p:nvSpPr>
+        <p:spPr>
+          <a:xfrm>
+            <a:off x="8759952" y="3355848"/>
+            <a:ext cx="2761488" cy="310896"/>
           </a:xfrm>
           <a:prstGeom prst="rect">
             <a:avLst/>
@@ -9219,7 +9447,7 @@
           <a:lstStyle/>
           <a:p>
             <a:pPr algn="l">
-              <a:defRPr sz="1100" b="0">
+              <a:defRPr sz="1000" b="0">
                 <a:solidFill>
                   <a:srgbClr val="C4D4EE"/>
                 </a:solidFill>
@@ -9234,14 +9462,14 @@
       </p:sp>
       <p:sp>
         <p:nvSpPr>
-          <p:cNvPr id="36" name="TextBox 35"/>
-          <p:cNvSpPr txBox="1"/>
-          <p:nvPr/>
-        </p:nvSpPr>
-        <p:spPr>
-          <a:xfrm>
-            <a:off x="6583680" y="4224528"/>
-            <a:ext cx="2468880" cy="329184"/>
+          <p:cNvPr id="42" name="TextBox 41"/>
+          <p:cNvSpPr txBox="1"/>
+          <p:nvPr/>
+        </p:nvSpPr>
+        <p:spPr>
+          <a:xfrm>
+            <a:off x="6537960" y="3694176"/>
+            <a:ext cx="2103120" cy="310896"/>
           </a:xfrm>
           <a:prstGeom prst="rect">
             <a:avLst/>
@@ -9255,7 +9483,7 @@
           <a:lstStyle/>
           <a:p>
             <a:pPr algn="l">
-              <a:defRPr sz="1200" b="1">
+              <a:defRPr sz="1000" b="1">
                 <a:solidFill>
                   <a:srgbClr val="3B82F6"/>
                 </a:solidFill>
@@ -9263,21 +9491,21 @@
               </a:defRPr>
             </a:pPr>
             <a:r>
-              <a:t>/Stop Wiki UI</a:t>
-            </a:r>
-          </a:p>
-        </p:txBody>
-      </p:sp>
-      <p:sp>
-        <p:nvSpPr>
-          <p:cNvPr id="37" name="TextBox 36"/>
-          <p:cNvSpPr txBox="1"/>
-          <p:nvPr/>
-        </p:nvSpPr>
-        <p:spPr>
-          <a:xfrm>
-            <a:off x="9144000" y="4224528"/>
-            <a:ext cx="2377440" cy="329184"/>
+              <a:t>Stop Wiki UI</a:t>
+            </a:r>
+          </a:p>
+        </p:txBody>
+      </p:sp>
+      <p:sp>
+        <p:nvSpPr>
+          <p:cNvPr id="43" name="TextBox 42"/>
+          <p:cNvSpPr txBox="1"/>
+          <p:nvPr/>
+        </p:nvSpPr>
+        <p:spPr>
+          <a:xfrm>
+            <a:off x="8759952" y="3694176"/>
+            <a:ext cx="2761488" cy="310896"/>
           </a:xfrm>
           <a:prstGeom prst="rect">
             <a:avLst/>
@@ -9291,7 +9519,7 @@
           <a:lstStyle/>
           <a:p>
             <a:pPr algn="l">
-              <a:defRPr sz="1100" b="0">
+              <a:defRPr sz="1000" b="0">
                 <a:solidFill>
                   <a:srgbClr val="C4D4EE"/>
                 </a:solidFill>
@@ -9306,14 +9534,57 @@
       </p:sp>
       <p:sp>
         <p:nvSpPr>
-          <p:cNvPr id="38" name="TextBox 37"/>
-          <p:cNvSpPr txBox="1"/>
-          <p:nvPr/>
-        </p:nvSpPr>
-        <p:spPr>
-          <a:xfrm>
-            <a:off x="6583680" y="4663440"/>
-            <a:ext cx="2468880" cy="329184"/>
+          <p:cNvPr id="44" name="Rectangle 43"/>
+          <p:cNvSpPr/>
+          <p:nvPr/>
+        </p:nvSpPr>
+        <p:spPr>
+          <a:xfrm>
+            <a:off x="6537960" y="4069080"/>
+            <a:ext cx="4956048" cy="12700"/>
+          </a:xfrm>
+          <a:prstGeom prst="rect">
+            <a:avLst/>
+          </a:prstGeom>
+          <a:solidFill>
+            <a:srgbClr val="233764"/>
+          </a:solidFill>
+          <a:ln>
+            <a:noFill/>
+          </a:ln>
+        </p:spPr>
+        <p:style>
+          <a:lnRef idx="1">
+            <a:schemeClr val="accent1"/>
+          </a:lnRef>
+          <a:fillRef idx="3">
+            <a:schemeClr val="accent1"/>
+          </a:fillRef>
+          <a:effectRef idx="2">
+            <a:schemeClr val="accent1"/>
+          </a:effectRef>
+          <a:fontRef idx="minor">
+            <a:schemeClr val="lt1"/>
+          </a:fontRef>
+        </p:style>
+        <p:txBody>
+          <a:bodyPr rtlCol="0" anchor="ctr"/>
+          <a:lstStyle/>
+          <a:p>
+            <a:pPr algn="ctr"/>
+          </a:p>
+        </p:txBody>
+      </p:sp>
+      <p:sp>
+        <p:nvSpPr>
+          <p:cNvPr id="45" name="TextBox 44"/>
+          <p:cNvSpPr txBox="1"/>
+          <p:nvPr/>
+        </p:nvSpPr>
+        <p:spPr>
+          <a:xfrm>
+            <a:off x="6537960" y="4142232"/>
+            <a:ext cx="2011680" cy="182880"/>
           </a:xfrm>
           <a:prstGeom prst="rect">
             <a:avLst/>
@@ -9327,29 +9598,65 @@
           <a:lstStyle/>
           <a:p>
             <a:pPr algn="l">
-              <a:defRPr sz="1200" b="1">
-                <a:solidFill>
-                  <a:srgbClr val="3B82F6"/>
+              <a:defRPr sz="900" b="1">
+                <a:solidFill>
+                  <a:srgbClr val="8B5CF6"/>
+                </a:solidFill>
+                <a:latin typeface="Calibri"/>
+              </a:defRPr>
+            </a:pPr>
+            <a:r>
+              <a:t>REPO MAINTENANCE</a:t>
+            </a:r>
+          </a:p>
+        </p:txBody>
+      </p:sp>
+      <p:sp>
+        <p:nvSpPr>
+          <p:cNvPr id="46" name="TextBox 45"/>
+          <p:cNvSpPr txBox="1"/>
+          <p:nvPr/>
+        </p:nvSpPr>
+        <p:spPr>
+          <a:xfrm>
+            <a:off x="6537960" y="4343400"/>
+            <a:ext cx="2103120" cy="310896"/>
+          </a:xfrm>
+          <a:prstGeom prst="rect">
+            <a:avLst/>
+          </a:prstGeom>
+          <a:noFill/>
+        </p:spPr>
+        <p:txBody>
+          <a:bodyPr wrap="square">
+            <a:spAutoFit/>
+          </a:bodyPr>
+          <a:lstStyle/>
+          <a:p>
+            <a:pPr algn="l">
+              <a:defRPr sz="1000" b="1">
+                <a:solidFill>
+                  <a:srgbClr val="8B5CF6"/>
                 </a:solidFill>
                 <a:latin typeface="Courier New"/>
               </a:defRPr>
             </a:pPr>
             <a:r>
-              <a:t>/Sync Docs</a:t>
-            </a:r>
-          </a:p>
-        </p:txBody>
-      </p:sp>
-      <p:sp>
-        <p:nvSpPr>
-          <p:cNvPr id="39" name="TextBox 38"/>
-          <p:cNvSpPr txBox="1"/>
-          <p:nvPr/>
-        </p:nvSpPr>
-        <p:spPr>
-          <a:xfrm>
-            <a:off x="9144000" y="4663440"/>
-            <a:ext cx="2377440" cy="329184"/>
+              <a:t>Sync Docs</a:t>
+            </a:r>
+          </a:p>
+        </p:txBody>
+      </p:sp>
+      <p:sp>
+        <p:nvSpPr>
+          <p:cNvPr id="47" name="TextBox 46"/>
+          <p:cNvSpPr txBox="1"/>
+          <p:nvPr/>
+        </p:nvSpPr>
+        <p:spPr>
+          <a:xfrm>
+            <a:off x="8759952" y="4343400"/>
+            <a:ext cx="2761488" cy="310896"/>
           </a:xfrm>
           <a:prstGeom prst="rect">
             <a:avLst/>
@@ -9363,7 +9670,7 @@
           <a:lstStyle/>
           <a:p>
             <a:pPr algn="l">
-              <a:defRPr sz="1100" b="0">
+              <a:defRPr sz="1000" b="0">
                 <a:solidFill>
                   <a:srgbClr val="C4D4EE"/>
                 </a:solidFill>
@@ -9371,21 +9678,21 @@
               </a:defRPr>
             </a:pPr>
             <a:r>
-              <a:t>Update README and documentation</a:t>
-            </a:r>
-          </a:p>
-        </p:txBody>
-      </p:sp>
-      <p:sp>
-        <p:nvSpPr>
-          <p:cNvPr id="40" name="TextBox 39"/>
-          <p:cNvSpPr txBox="1"/>
-          <p:nvPr/>
-        </p:nvSpPr>
-        <p:spPr>
-          <a:xfrm>
-            <a:off x="6583680" y="5102352"/>
-            <a:ext cx="2468880" cy="329184"/>
+              <a:t>Sync README and documentation</a:t>
+            </a:r>
+          </a:p>
+        </p:txBody>
+      </p:sp>
+      <p:sp>
+        <p:nvSpPr>
+          <p:cNvPr id="48" name="TextBox 47"/>
+          <p:cNvSpPr txBox="1"/>
+          <p:nvPr/>
+        </p:nvSpPr>
+        <p:spPr>
+          <a:xfrm>
+            <a:off x="6537960" y="4681728"/>
+            <a:ext cx="2103120" cy="310896"/>
           </a:xfrm>
           <a:prstGeom prst="rect">
             <a:avLst/>
@@ -9399,29 +9706,29 @@
           <a:lstStyle/>
           <a:p>
             <a:pPr algn="l">
-              <a:defRPr sz="1200" b="1">
-                <a:solidFill>
-                  <a:srgbClr val="3B82F6"/>
+              <a:defRPr sz="1000" b="1">
+                <a:solidFill>
+                  <a:srgbClr val="8B5CF6"/>
                 </a:solidFill>
                 <a:latin typeface="Courier New"/>
               </a:defRPr>
             </a:pPr>
             <a:r>
-              <a:t>/Run Maintenance</a:t>
-            </a:r>
-          </a:p>
-        </p:txBody>
-      </p:sp>
-      <p:sp>
-        <p:nvSpPr>
-          <p:cNvPr id="41" name="TextBox 40"/>
-          <p:cNvSpPr txBox="1"/>
-          <p:nvPr/>
-        </p:nvSpPr>
-        <p:spPr>
-          <a:xfrm>
-            <a:off x="9144000" y="5102352"/>
-            <a:ext cx="2377440" cy="329184"/>
+              <a:t>Run Maintenance</a:t>
+            </a:r>
+          </a:p>
+        </p:txBody>
+      </p:sp>
+      <p:sp>
+        <p:nvSpPr>
+          <p:cNvPr id="49" name="TextBox 48"/>
+          <p:cNvSpPr txBox="1"/>
+          <p:nvPr/>
+        </p:nvSpPr>
+        <p:spPr>
+          <a:xfrm>
+            <a:off x="8759952" y="4681728"/>
+            <a:ext cx="2761488" cy="310896"/>
           </a:xfrm>
           <a:prstGeom prst="rect">
             <a:avLst/>
@@ -9435,7 +9742,7 @@
           <a:lstStyle/>
           <a:p>
             <a:pPr algn="l">
-              <a:defRPr sz="1100" b="0">
+              <a:defRPr sz="1000" b="0">
                 <a:solidFill>
                   <a:srgbClr val="C4D4EE"/>
                 </a:solidFill>
@@ -9443,21 +9750,93 @@
               </a:defRPr>
             </a:pPr>
             <a:r>
-              <a:t>Run tests, verify skills, check git health</a:t>
-            </a:r>
-          </a:p>
-        </p:txBody>
-      </p:sp>
-      <p:sp>
-        <p:nvSpPr>
-          <p:cNvPr id="42" name="Rounded Rectangle 41"/>
+              <a:t>Run tests, verify skills, git health</a:t>
+            </a:r>
+          </a:p>
+        </p:txBody>
+      </p:sp>
+      <p:sp>
+        <p:nvSpPr>
+          <p:cNvPr id="50" name="TextBox 49"/>
+          <p:cNvSpPr txBox="1"/>
+          <p:nvPr/>
+        </p:nvSpPr>
+        <p:spPr>
+          <a:xfrm>
+            <a:off x="6537960" y="5020056"/>
+            <a:ext cx="2103120" cy="310896"/>
+          </a:xfrm>
+          <a:prstGeom prst="rect">
+            <a:avLst/>
+          </a:prstGeom>
+          <a:noFill/>
+        </p:spPr>
+        <p:txBody>
+          <a:bodyPr wrap="square">
+            <a:spAutoFit/>
+          </a:bodyPr>
+          <a:lstStyle/>
+          <a:p>
+            <a:pPr algn="l">
+              <a:defRPr sz="1000" b="1">
+                <a:solidFill>
+                  <a:srgbClr val="8B5CF6"/>
+                </a:solidFill>
+                <a:latin typeface="Courier New"/>
+              </a:defRPr>
+            </a:pPr>
+            <a:r>
+              <a:t>Regenerate Presentation</a:t>
+            </a:r>
+          </a:p>
+        </p:txBody>
+      </p:sp>
+      <p:sp>
+        <p:nvSpPr>
+          <p:cNvPr id="51" name="TextBox 50"/>
+          <p:cNvSpPr txBox="1"/>
+          <p:nvPr/>
+        </p:nvSpPr>
+        <p:spPr>
+          <a:xfrm>
+            <a:off x="8759952" y="5020056"/>
+            <a:ext cx="2761488" cy="310896"/>
+          </a:xfrm>
+          <a:prstGeom prst="rect">
+            <a:avLst/>
+          </a:prstGeom>
+          <a:noFill/>
+        </p:spPr>
+        <p:txBody>
+          <a:bodyPr wrap="square">
+            <a:spAutoFit/>
+          </a:bodyPr>
+          <a:lstStyle/>
+          <a:p>
+            <a:pPr algn="l">
+              <a:defRPr sz="1000" b="0">
+                <a:solidFill>
+                  <a:srgbClr val="C4D4EE"/>
+                </a:solidFill>
+                <a:latin typeface="Calibri"/>
+              </a:defRPr>
+            </a:pPr>
+            <a:r>
+              <a:t>Rebuild demo videos and PPTX deck</a:t>
+            </a:r>
+          </a:p>
+        </p:txBody>
+      </p:sp>
+      <p:sp>
+        <p:nvSpPr>
+          <p:cNvPr id="52" name="Rounded Rectangle 51"/>
           <p:cNvSpPr/>
           <p:nvPr/>
         </p:nvSpPr>
         <p:spPr>
           <a:xfrm>
-            <a:off x="502920" y="5687568"/>
-            <a:ext cx="11201400" cy="960120"/>
+            <a:off x="502920" y="5532120"/>
+            <a:ext cx="11201400" cy="987552"/>
           </a:xfrm>
           <a:prstGeom prst="roundRect">
             <a:avLst/>
@@ -9495,14 +9874,57 @@
       </p:sp>
       <p:sp>
         <p:nvSpPr>
-          <p:cNvPr id="43" name="TextBox 42"/>
-          <p:cNvSpPr txBox="1"/>
-          <p:nvPr/>
-        </p:nvSpPr>
-        <p:spPr>
-          <a:xfrm>
-            <a:off x="685800" y="5779008"/>
-            <a:ext cx="2286000" cy="347472"/>
+          <p:cNvPr id="53" name="Rectangle 52"/>
+          <p:cNvSpPr/>
+          <p:nvPr/>
+        </p:nvSpPr>
+        <p:spPr>
+          <a:xfrm>
+            <a:off x="502920" y="5532120"/>
+            <a:ext cx="64008" cy="987552"/>
+          </a:xfrm>
+          <a:prstGeom prst="rect">
+            <a:avLst/>
+          </a:prstGeom>
+          <a:solidFill>
+            <a:srgbClr val="06B6D4"/>
+          </a:solidFill>
+          <a:ln>
+            <a:noFill/>
+          </a:ln>
+        </p:spPr>
+        <p:style>
+          <a:lnRef idx="1">
+            <a:schemeClr val="accent1"/>
+          </a:lnRef>
+          <a:fillRef idx="3">
+            <a:schemeClr val="accent1"/>
+          </a:fillRef>
+          <a:effectRef idx="2">
+            <a:schemeClr val="accent1"/>
+          </a:effectRef>
+          <a:fontRef idx="minor">
+            <a:schemeClr val="lt1"/>
+          </a:fontRef>
+        </p:style>
+        <p:txBody>
+          <a:bodyPr rtlCol="0" anchor="ctr"/>
+          <a:lstStyle/>
+          <a:p>
+            <a:pPr algn="ctr"/>
+          </a:p>
+        </p:txBody>
+      </p:sp>
+      <p:sp>
+        <p:nvSpPr>
+          <p:cNvPr id="54" name="TextBox 53"/>
+          <p:cNvSpPr txBox="1"/>
+          <p:nvPr/>
+        </p:nvSpPr>
+        <p:spPr>
+          <a:xfrm>
+            <a:off x="685800" y="5623560"/>
+            <a:ext cx="2377440" cy="347472"/>
           </a:xfrm>
           <a:prstGeom prst="rect">
             <a:avLst/>
@@ -9516,7 +9938,7 @@
           <a:lstStyle/>
           <a:p>
             <a:pPr algn="l">
-              <a:defRPr sz="1300" b="1">
+              <a:defRPr sz="1200" b="1">
                 <a:solidFill>
                   <a:srgbClr val="06B6D4"/>
                 </a:solidFill>
@@ -9531,14 +9953,14 @@
       </p:sp>
       <p:sp>
         <p:nvSpPr>
-          <p:cNvPr id="44" name="TextBox 43"/>
-          <p:cNvSpPr txBox="1"/>
-          <p:nvPr/>
-        </p:nvSpPr>
-        <p:spPr>
-          <a:xfrm>
-            <a:off x="3200400" y="5779008"/>
-            <a:ext cx="1691640" cy="384048"/>
+          <p:cNvPr id="55" name="TextBox 54"/>
+          <p:cNvSpPr txBox="1"/>
+          <p:nvPr/>
+        </p:nvSpPr>
+        <p:spPr>
+          <a:xfrm>
+            <a:off x="685800" y="6035040"/>
+            <a:ext cx="2377440" cy="256032"/>
           </a:xfrm>
           <a:prstGeom prst="rect">
             <a:avLst/>
@@ -9552,7 +9974,43 @@
           <a:lstStyle/>
           <a:p>
             <a:pPr algn="l">
-              <a:defRPr sz="1200" b="0">
+              <a:defRPr sz="900" b="0">
+                <a:solidFill>
+                  <a:srgbClr val="6982AC"/>
+                </a:solidFill>
+                <a:latin typeface="Calibri"/>
+              </a:defRPr>
+            </a:pPr>
+            <a:r>
+              <a:t>Multi-provider · Grounded</a:t>
+            </a:r>
+          </a:p>
+        </p:txBody>
+      </p:sp>
+      <p:sp>
+        <p:nvSpPr>
+          <p:cNvPr id="56" name="TextBox 55"/>
+          <p:cNvSpPr txBox="1"/>
+          <p:nvPr/>
+        </p:nvSpPr>
+        <p:spPr>
+          <a:xfrm>
+            <a:off x="3108960" y="5623560"/>
+            <a:ext cx="2103120" cy="329184"/>
+          </a:xfrm>
+          <a:prstGeom prst="rect">
+            <a:avLst/>
+          </a:prstGeom>
+          <a:noFill/>
+        </p:spPr>
+        <p:txBody>
+          <a:bodyPr wrap="square">
+            <a:spAutoFit/>
+          </a:bodyPr>
+          <a:lstStyle/>
+          <a:p>
+            <a:pPr algn="l">
+              <a:defRPr sz="1100" b="1">
                 <a:solidFill>
                   <a:srgbClr val="C4D4EE"/>
                 </a:solidFill>
@@ -9560,21 +10018,21 @@
               </a:defRPr>
             </a:pPr>
             <a:r>
-              <a:t>· API key validation</a:t>
-            </a:r>
-          </a:p>
-        </p:txBody>
-      </p:sp>
-      <p:sp>
-        <p:nvSpPr>
-          <p:cNvPr id="45" name="TextBox 44"/>
-          <p:cNvSpPr txBox="1"/>
-          <p:nvPr/>
-        </p:nvSpPr>
-        <p:spPr>
-          <a:xfrm>
-            <a:off x="4919472" y="5779008"/>
-            <a:ext cx="1691640" cy="384048"/>
+              <a:t>· Multi-provider Q&amp;A</a:t>
+            </a:r>
+          </a:p>
+        </p:txBody>
+      </p:sp>
+      <p:sp>
+        <p:nvSpPr>
+          <p:cNvPr id="57" name="TextBox 56"/>
+          <p:cNvSpPr txBox="1"/>
+          <p:nvPr/>
+        </p:nvSpPr>
+        <p:spPr>
+          <a:xfrm>
+            <a:off x="3108960" y="6035040"/>
+            <a:ext cx="2103120" cy="256032"/>
           </a:xfrm>
           <a:prstGeom prst="rect">
             <a:avLst/>
@@ -9588,7 +10046,43 @@
           <a:lstStyle/>
           <a:p>
             <a:pPr algn="l">
-              <a:defRPr sz="1200" b="0">
+              <a:defRPr sz="900" b="0">
+                <a:solidFill>
+                  <a:srgbClr val="6982AC"/>
+                </a:solidFill>
+                <a:latin typeface="Calibri"/>
+              </a:defRPr>
+            </a:pPr>
+            <a:r>
+              <a:t>Anthropic · OpenAI · Google · Mistral · Cohere</a:t>
+            </a:r>
+          </a:p>
+        </p:txBody>
+      </p:sp>
+      <p:sp>
+        <p:nvSpPr>
+          <p:cNvPr id="58" name="TextBox 57"/>
+          <p:cNvSpPr txBox="1"/>
+          <p:nvPr/>
+        </p:nvSpPr>
+        <p:spPr>
+          <a:xfrm>
+            <a:off x="5257800" y="5623560"/>
+            <a:ext cx="2103120" cy="329184"/>
+          </a:xfrm>
+          <a:prstGeom prst="rect">
+            <a:avLst/>
+          </a:prstGeom>
+          <a:noFill/>
+        </p:spPr>
+        <p:txBody>
+          <a:bodyPr wrap="square">
+            <a:spAutoFit/>
+          </a:bodyPr>
+          <a:lstStyle/>
+          <a:p>
+            <a:pPr algn="l">
+              <a:defRPr sz="1100" b="1">
                 <a:solidFill>
                   <a:srgbClr val="C4D4EE"/>
                 </a:solidFill>
@@ -9596,21 +10090,21 @@
               </a:defRPr>
             </a:pPr>
             <a:r>
-              <a:t>· Wiki page browser</a:t>
-            </a:r>
-          </a:p>
-        </p:txBody>
-      </p:sp>
-      <p:sp>
-        <p:nvSpPr>
-          <p:cNvPr id="46" name="TextBox 45"/>
-          <p:cNvSpPr txBox="1"/>
-          <p:nvPr/>
-        </p:nvSpPr>
-        <p:spPr>
-          <a:xfrm>
-            <a:off x="6638544" y="5779008"/>
-            <a:ext cx="1691640" cy="384048"/>
+              <a:t>· Wiki-grounded answers</a:t>
+            </a:r>
+          </a:p>
+        </p:txBody>
+      </p:sp>
+      <p:sp>
+        <p:nvSpPr>
+          <p:cNvPr id="59" name="TextBox 58"/>
+          <p:cNvSpPr txBox="1"/>
+          <p:nvPr/>
+        </p:nvSpPr>
+        <p:spPr>
+          <a:xfrm>
+            <a:off x="5257800" y="6035040"/>
+            <a:ext cx="2103120" cy="256032"/>
           </a:xfrm>
           <a:prstGeom prst="rect">
             <a:avLst/>
@@ -9624,7 +10118,43 @@
           <a:lstStyle/>
           <a:p>
             <a:pPr algn="l">
-              <a:defRPr sz="1200" b="0">
+              <a:defRPr sz="900" b="0">
+                <a:solidFill>
+                  <a:srgbClr val="6982AC"/>
+                </a:solidFill>
+                <a:latin typeface="Calibri"/>
+              </a:defRPr>
+            </a:pPr>
+            <a:r>
+              <a:t>No hallucination outside wiki content</a:t>
+            </a:r>
+          </a:p>
+        </p:txBody>
+      </p:sp>
+      <p:sp>
+        <p:nvSpPr>
+          <p:cNvPr id="60" name="TextBox 59"/>
+          <p:cNvSpPr txBox="1"/>
+          <p:nvPr/>
+        </p:nvSpPr>
+        <p:spPr>
+          <a:xfrm>
+            <a:off x="7406640" y="5623560"/>
+            <a:ext cx="2103120" cy="329184"/>
+          </a:xfrm>
+          <a:prstGeom prst="rect">
+            <a:avLst/>
+          </a:prstGeom>
+          <a:noFill/>
+        </p:spPr>
+        <p:txBody>
+          <a:bodyPr wrap="square">
+            <a:spAutoFit/>
+          </a:bodyPr>
+          <a:lstStyle/>
+          <a:p>
+            <a:pPr algn="l">
+              <a:defRPr sz="1100" b="1">
                 <a:solidFill>
                   <a:srgbClr val="C4D4EE"/>
                 </a:solidFill>
@@ -9632,21 +10162,21 @@
               </a:defRPr>
             </a:pPr>
             <a:r>
-              <a:t>· Claude-powered Q&amp;A</a:t>
-            </a:r>
-          </a:p>
-        </p:txBody>
-      </p:sp>
-      <p:sp>
-        <p:nvSpPr>
-          <p:cNvPr id="47" name="TextBox 46"/>
-          <p:cNvSpPr txBox="1"/>
-          <p:nvPr/>
-        </p:nvSpPr>
-        <p:spPr>
-          <a:xfrm>
-            <a:off x="8357616" y="5779008"/>
-            <a:ext cx="1691640" cy="384048"/>
+              <a:t>· API key + model validation</a:t>
+            </a:r>
+          </a:p>
+        </p:txBody>
+      </p:sp>
+      <p:sp>
+        <p:nvSpPr>
+          <p:cNvPr id="61" name="TextBox 60"/>
+          <p:cNvSpPr txBox="1"/>
+          <p:nvPr/>
+        </p:nvSpPr>
+        <p:spPr>
+          <a:xfrm>
+            <a:off x="7406640" y="6035040"/>
+            <a:ext cx="2103120" cy="256032"/>
           </a:xfrm>
           <a:prstGeom prst="rect">
             <a:avLst/>
@@ -9660,7 +10190,43 @@
           <a:lstStyle/>
           <a:p>
             <a:pPr algn="l">
-              <a:defRPr sz="1200" b="0">
+              <a:defRPr sz="900" b="0">
+                <a:solidFill>
+                  <a:srgbClr val="6982AC"/>
+                </a:solidFill>
+                <a:latin typeface="Calibri"/>
+              </a:defRPr>
+            </a:pPr>
+            <a:r>
+              <a:t>Session memory — never saved to disk</a:t>
+            </a:r>
+          </a:p>
+        </p:txBody>
+      </p:sp>
+      <p:sp>
+        <p:nvSpPr>
+          <p:cNvPr id="62" name="TextBox 61"/>
+          <p:cNvSpPr txBox="1"/>
+          <p:nvPr/>
+        </p:nvSpPr>
+        <p:spPr>
+          <a:xfrm>
+            <a:off x="9555480" y="5623560"/>
+            <a:ext cx="2103120" cy="329184"/>
+          </a:xfrm>
+          <a:prstGeom prst="rect">
+            <a:avLst/>
+          </a:prstGeom>
+          <a:noFill/>
+        </p:spPr>
+        <p:txBody>
+          <a:bodyPr wrap="square">
+            <a:spAutoFit/>
+          </a:bodyPr>
+          <a:lstStyle/>
+          <a:p>
+            <a:pPr algn="l">
+              <a:defRPr sz="1100" b="1">
                 <a:solidFill>
                   <a:srgbClr val="C4D4EE"/>
                 </a:solidFill>
@@ -9668,21 +10234,21 @@
               </a:defRPr>
             </a:pPr>
             <a:r>
-              <a:t>· Token + cache metrics</a:t>
-            </a:r>
-          </a:p>
-        </p:txBody>
-      </p:sp>
-      <p:sp>
-        <p:nvSpPr>
-          <p:cNvPr id="48" name="TextBox 47"/>
-          <p:cNvSpPr txBox="1"/>
-          <p:nvPr/>
-        </p:nvSpPr>
-        <p:spPr>
-          <a:xfrm>
-            <a:off x="10076688" y="5779008"/>
-            <a:ext cx="1691640" cy="384048"/>
+              <a:t>· Explicit 'not found'</a:t>
+            </a:r>
+          </a:p>
+        </p:txBody>
+      </p:sp>
+      <p:sp>
+        <p:nvSpPr>
+          <p:cNvPr id="63" name="TextBox 62"/>
+          <p:cNvSpPr txBox="1"/>
+          <p:nvPr/>
+        </p:nvSpPr>
+        <p:spPr>
+          <a:xfrm>
+            <a:off x="9555480" y="6035040"/>
+            <a:ext cx="2103120" cy="256032"/>
           </a:xfrm>
           <a:prstGeom prst="rect">
             <a:avLst/>
@@ -9696,51 +10262,15 @@
           <a:lstStyle/>
           <a:p>
             <a:pPr algn="l">
-              <a:defRPr sz="1200" b="0">
-                <a:solidFill>
-                  <a:srgbClr val="C4D4EE"/>
+              <a:defRPr sz="900" b="0">
+                <a:solidFill>
+                  <a:srgbClr val="6982AC"/>
                 </a:solidFill>
                 <a:latin typeface="Calibri"/>
               </a:defRPr>
             </a:pPr>
             <a:r>
-              <a:t>· Secure (session memory)</a:t>
-            </a:r>
-          </a:p>
-        </p:txBody>
-      </p:sp>
-      <p:sp>
-        <p:nvSpPr>
-          <p:cNvPr id="49" name="TextBox 48"/>
-          <p:cNvSpPr txBox="1"/>
-          <p:nvPr/>
-        </p:nvSpPr>
-        <p:spPr>
-          <a:xfrm>
-            <a:off x="11795760" y="5779008"/>
-            <a:ext cx="1691640" cy="384048"/>
-          </a:xfrm>
-          <a:prstGeom prst="rect">
-            <a:avLst/>
-          </a:prstGeom>
-          <a:noFill/>
-        </p:spPr>
-        <p:txBody>
-          <a:bodyPr wrap="square">
-            <a:spAutoFit/>
-          </a:bodyPr>
-          <a:lstStyle/>
-          <a:p>
-            <a:pPr algn="l">
-              <a:defRPr sz="1200" b="0">
-                <a:solidFill>
-                  <a:srgbClr val="C4D4EE"/>
-                </a:solidFill>
-                <a:latin typeface="Calibri"/>
-              </a:defRPr>
-            </a:pPr>
-            <a:r>
-              <a:t>· Explicit 'not found' responses</a:t>
+              <a:t>Clear signal when topic is outside wiki</a:t>
             </a:r>
           </a:p>
         </p:txBody>

</xml_diff>